<commit_message>
Address v0.2.0 review: keep v0.1 rendering, harden new keys
- Integer category references stay indexes; strings are names
- Line chart axes span their data; bars keep zero
- colors.series_mode defaults to automatic: a brand's own series palette is kept
- Lint reports malformed min/max, waterfall start/steps, estimates,
  next_steps and summary sections instead of crashing
- Measure tracker tabs and mono text in the monospace face (TTC index aware,
  fc-match timeout); normalise language codes such as ko-KR
- Matrix commentary uses the shared commentary column
- CHANGELOG lists every changed default with its opt-out

Co-Authored-By: Claude Opus 5.5 <noreply@anthropic.com>
</commit_message>
<xml_diff>
--- a/docs/examples/exhibits.pptx
+++ b/docs/examples/exhibits.pptx
@@ -2698,7 +2698,7 @@
         <c:axId val="2140495176"/>
         <c:scaling>
           <c:max val="60.0"/>
-          <c:min val="0.0"/>
+          <c:min val="10.0"/>
         </c:scaling>
         <c:delete val="0"/>
         <c:axPos val="l"/>
@@ -2731,7 +2731,7 @@
         <c:crossAx val="2118791784"/>
         <c:crosses val="autoZero"/>
         <c:crossBetween val="between"/>
-        <c:majorUnit val="20.0"/>
+        <c:majorUnit val="10.0"/>
       </c:valAx>
       <c:spPr>
         <a:noFill/>
@@ -8903,7 +8903,7 @@
         </p:nvCxnSpPr>
         <p:spPr>
           <a:xfrm>
-            <a:off x="1072880" y="2990934"/>
+            <a:off x="1072880" y="3205073"/>
             <a:ext cx="9442312" cy="0"/>
           </a:xfrm>
           <a:prstGeom prst="line">
@@ -8925,7 +8925,7 @@
         </p:nvSpPr>
         <p:spPr>
           <a:xfrm>
-            <a:off x="10616792" y="2301468"/>
+            <a:off x="10616792" y="2397831"/>
             <a:ext cx="662273" cy="201168"/>
           </a:xfrm>
           <a:prstGeom prst="rect">
@@ -8977,7 +8977,7 @@
         </p:nvSpPr>
         <p:spPr>
           <a:xfrm>
-            <a:off x="10616792" y="2890350"/>
+            <a:off x="10616792" y="3104489"/>
             <a:ext cx="670266" cy="201168"/>
           </a:xfrm>
           <a:prstGeom prst="rect">
@@ -9018,7 +9018,7 @@
         </p:nvSpPr>
         <p:spPr>
           <a:xfrm>
-            <a:off x="10616792" y="3091518"/>
+            <a:off x="10616792" y="3305657"/>
             <a:ext cx="598974" cy="201168"/>
           </a:xfrm>
           <a:prstGeom prst="rect">
@@ -9070,7 +9070,7 @@
         </p:nvSpPr>
         <p:spPr>
           <a:xfrm>
-            <a:off x="10616792" y="3292686"/>
+            <a:off x="10616792" y="3506825"/>
             <a:ext cx="686207" cy="201168"/>
           </a:xfrm>
           <a:prstGeom prst="rect">
@@ -9122,7 +9122,7 @@
         </p:nvSpPr>
         <p:spPr>
           <a:xfrm>
-            <a:off x="10616792" y="3493854"/>
+            <a:off x="10616792" y="3746906"/>
             <a:ext cx="635845" cy="201168"/>
           </a:xfrm>
           <a:prstGeom prst="rect">
@@ -15295,7 +15295,7 @@
                 <a:ea typeface="Malgun Gothic"/>
                 <a:cs typeface="Arial"/>
               </a:rPr>
-              <a:t>1) Answers "likely" and "very likely" combined.  Figures may not add up to the totals shown because of rounding.</a:t>
+              <a:t>1) Answers "likely" and "very likely" combined.  Totals may differ because of rounding.</a:t>
             </a:r>
           </a:p>
           <a:p>

</xml_diff>